<commit_message>
Add GitHub repo link to closing and live-demo slides
Co-Authored-By: Claude Sonnet 5 <noreply@anthropic.com>
</commit_message>
<xml_diff>
--- a/pitch/vyapari-mitra-deck.pptx
+++ b/pitch/vyapari-mitra-deck.pptx
@@ -4241,6 +4241,66 @@
           </a:p>
         </p:txBody>
       </p:sp>
+      <p:sp>
+        <p:nvSpPr>
+          <p:cNvPr id="8" name="Text 5"/>
+          <p:cNvSpPr txBox="1"/>
+          <p:nvPr/>
+        </p:nvSpPr>
+        <p:spPr>
+          <a:xfrm>
+            <a:off x="822960" y="6355080"/>
+            <a:ext cx="10515600" cy="320040"/>
+          </a:xfrm>
+          <a:prstGeom prst="rect">
+            <a:avLst/>
+          </a:prstGeom>
+          <a:noFill/>
+          <a:ln/>
+        </p:spPr>
+        <p:txBody>
+          <a:bodyPr wrap="square" lIns="0" tIns="0" rIns="0" bIns="0" rtlCol="0" anchor="ctr"/>
+          <a:lstStyle/>
+          <a:p>
+            <a:pPr indent="0" marL="0">
+              <a:buNone/>
+            </a:pPr>
+            <a:r>
+              <a:rPr lang="en-US" sz="1250" dirty="0">
+                <a:solidFill>
+                  <a:srgbClr val="6B7686"/>
+                </a:solidFill>
+                <a:latin typeface="Calibri" pitchFamily="34" charset="0"/>
+                <a:ea typeface="Calibri" pitchFamily="34" charset="-122"/>
+                <a:cs typeface="Calibri" pitchFamily="34" charset="-120"/>
+              </a:rPr>
+              <a:t>Code &amp; working prototype: </a:t>
+            </a:r>
+            <a:pPr indent="0" marL="0">
+              <a:buNone/>
+            </a:pPr>
+            <a:r>
+              <a:rPr lang="en-US" sz="1250" b="1" u="sng" dirty="0">
+                <a:solidFill>
+                  <a:srgbClr val="0090C4"/>
+                </a:solidFill>
+                <a:latin typeface="Calibri" pitchFamily="34" charset="0"/>
+                <a:ea typeface="Calibri" pitchFamily="34" charset="-122"/>
+                <a:cs typeface="Calibri" pitchFamily="34" charset="-120"/>
+                <a:hlinkClick r:id="rId2" invalidUrl="" action="" tgtFrame="" tooltip="" history="1" highlightClick="0" endSnd="0">
+                  <a:extLst>
+                    <a:ext uri="{A12FA001-AC4F-418D-AE19-62706E023703}">
+                      <ahyp:hlinkClr xmlns:ahyp="http://schemas.microsoft.com/office/drawing/2018/hyperlinkcolor" val="tx"/>
+                    </a:ext>
+                  </a:extLst>
+                </a:hlinkClick>
+              </a:rPr>
+              <a:t>github.com/Ayush-170906/vyapari-mitra</a:t>
+            </a:r>
+            <a:endParaRPr lang="en-US" sz="1250" dirty="0"/>
+          </a:p>
+        </p:txBody>
+      </p:sp>
     </p:spTree>
   </p:cSld>
   <p:clrMapOvr>
@@ -7162,7 +7222,7 @@
         <p:spPr>
           <a:xfrm>
             <a:off x="640080" y="1051560"/>
-            <a:ext cx="7315200" cy="365760"/>
+            <a:ext cx="7040880" cy="365760"/>
           </a:xfrm>
           <a:prstGeom prst="rect">
             <a:avLst/>
@@ -7178,7 +7238,7 @@
               <a:buNone/>
             </a:pPr>
             <a:r>
-              <a:rPr lang="en-US" sz="1300" i="1" dirty="0">
+              <a:rPr lang="en-US" sz="1200" i="1" dirty="0">
                 <a:solidFill>
                   <a:srgbClr val="6B7686"/>
                 </a:solidFill>
@@ -7186,9 +7246,30 @@
                 <a:ea typeface="Calibri" pitchFamily="34" charset="-122"/>
                 <a:cs typeface="Calibri" pitchFamily="34" charset="-120"/>
               </a:rPr>
-              <a:t>Working prototype · web app · Sarvam-105B model</a:t>
-            </a:r>
-            <a:endParaRPr lang="en-US" sz="1300" dirty="0"/>
+              <a:t>Working prototype · web app · Sarvam-105B model  ·  </a:t>
+            </a:r>
+            <a:pPr indent="0" marL="0">
+              <a:buNone/>
+            </a:pPr>
+            <a:r>
+              <a:rPr lang="en-US" sz="1200" b="1" u="sng" dirty="0">
+                <a:solidFill>
+                  <a:srgbClr val="0090C4"/>
+                </a:solidFill>
+                <a:latin typeface="Calibri" pitchFamily="34" charset="0"/>
+                <a:ea typeface="Calibri" pitchFamily="34" charset="-122"/>
+                <a:cs typeface="Calibri" pitchFamily="34" charset="-120"/>
+                <a:hlinkClick r:id="rId1" invalidUrl="" action="" tgtFrame="" tooltip="" history="1" highlightClick="0" endSnd="0">
+                  <a:extLst>
+                    <a:ext uri="{A12FA001-AC4F-418D-AE19-62706E023703}">
+                      <ahyp:hlinkClr xmlns:ahyp="http://schemas.microsoft.com/office/drawing/2018/hyperlinkcolor" val="tx"/>
+                    </a:ext>
+                  </a:extLst>
+                </a:hlinkClick>
+              </a:rPr>
+              <a:t>github.com/Ayush-170906/vyapari-mitra</a:t>
+            </a:r>
+            <a:endParaRPr lang="en-US" sz="1200" dirty="0"/>
           </a:p>
         </p:txBody>
       </p:sp>
@@ -7230,7 +7311,7 @@
           <p:nvPr/>
         </p:nvPicPr>
         <p:blipFill>
-          <a:blip r:embed="rId1"/>
+          <a:blip r:embed="rId2"/>
           <a:srcRect l="0" r="0" t="0" b="0"/>
           <a:stretch/>
         </p:blipFill>

</xml_diff>